<commit_message>
fix(report-slides): preserve native text layout
</commit_message>
<xml_diff>
--- a/examples/report-slides/visual-authoring/deck.pptx
+++ b/examples/report-slides/visual-authoring/deck.pptx
@@ -3696,10 +3696,139 @@
           </a:fontRef>
         </p:style>
         <p:txBody>
-          <a:bodyPr rtlCol="0" anchor="ctr"/>
-          <a:lstStyle/>
-          <a:p>
-            <a:pPr algn="ctr"/>
+          <a:bodyPr rtlCol="0" anchor="t" wrap="none" lIns="0" rIns="0" tIns="325120" bIns="0"/>
+          <a:lstStyle/>
+          <a:p>
+            <a:pPr algn="ctr">
+              <a:lnSpc>
+                <a:spcPts val="1152"/>
+              </a:lnSpc>
+              <a:spcBef>
+                <a:spcPts val="0"/>
+              </a:spcBef>
+              <a:spcAft>
+                <a:spcPts val="0"/>
+              </a:spcAft>
+            </a:pPr>
+            <a:r>
+              <a:rPr sz="1200" b="1">
+                <a:solidFill>
+                  <a:srgbClr val="6E899D"/>
+                </a:solidFill>
+                <a:latin typeface="Arial"/>
+              </a:rPr>
+              <a:t>01</a:t>
+            </a:r>
+          </a:p>
+          <a:p>
+            <a:pPr algn="ctr">
+              <a:lnSpc>
+                <a:spcPts val="1728"/>
+              </a:lnSpc>
+              <a:spcBef>
+                <a:spcPts val="7328"/>
+              </a:spcBef>
+              <a:spcAft>
+                <a:spcPts val="0"/>
+              </a:spcAft>
+            </a:pPr>
+            <a:r>
+              <a:rPr sz="1800" b="1">
+                <a:solidFill>
+                  <a:srgbClr val="15334A"/>
+                </a:solidFill>
+                <a:latin typeface="Arial"/>
+              </a:rPr>
+              <a:t>Data sources</a:t>
+            </a:r>
+          </a:p>
+          <a:p>
+            <a:pPr algn="ctr">
+              <a:lnSpc>
+                <a:spcPts val="1344"/>
+              </a:lnSpc>
+              <a:spcBef>
+                <a:spcPts val="1712"/>
+              </a:spcBef>
+              <a:spcAft>
+                <a:spcPts val="0"/>
+              </a:spcAft>
+            </a:pPr>
+            <a:r>
+              <a:rPr sz="1400">
+                <a:solidFill>
+                  <a:srgbClr val="557085"/>
+                </a:solidFill>
+                <a:latin typeface="Arial"/>
+              </a:rPr>
+              <a:t>Raw inputs &amp;</a:t>
+            </a:r>
+          </a:p>
+          <a:p>
+            <a:pPr algn="ctr">
+              <a:lnSpc>
+                <a:spcPts val="1344"/>
+              </a:lnSpc>
+              <a:spcBef>
+                <a:spcPts val="336"/>
+              </a:spcBef>
+              <a:spcAft>
+                <a:spcPts val="0"/>
+              </a:spcAft>
+            </a:pPr>
+            <a:r>
+              <a:rPr sz="1400">
+                <a:solidFill>
+                  <a:srgbClr val="557085"/>
+                </a:solidFill>
+                <a:latin typeface="Arial"/>
+              </a:rPr>
+              <a:t>metadata</a:t>
+            </a:r>
+          </a:p>
+          <a:p>
+            <a:pPr algn="ctr">
+              <a:lnSpc>
+                <a:spcPts val="960"/>
+              </a:lnSpc>
+              <a:spcBef>
+                <a:spcPts val="3456"/>
+              </a:spcBef>
+              <a:spcAft>
+                <a:spcPts val="0"/>
+              </a:spcAft>
+            </a:pPr>
+            <a:r>
+              <a:rPr sz="1000" b="1">
+                <a:solidFill>
+                  <a:srgbClr val="7892A4"/>
+                </a:solidFill>
+                <a:latin typeface="Arial"/>
+              </a:rPr>
+              <a:t>OUTPUT</a:t>
+            </a:r>
+          </a:p>
+          <a:p>
+            <a:pPr algn="r">
+              <a:lnSpc>
+                <a:spcPts val="1056"/>
+              </a:lnSpc>
+              <a:spcBef>
+                <a:spcPts val="0"/>
+              </a:spcBef>
+              <a:spcAft>
+                <a:spcPts val="0"/>
+              </a:spcAft>
+            </a:pPr>
+            <a:r>
+              <a:rPr sz="1100" b="1">
+                <a:solidFill>
+                  <a:srgbClr val="4F86A3"/>
+                </a:solidFill>
+                <a:latin typeface="Arial"/>
+              </a:rPr>
+              <a:t>DATASET</a:t>
+            </a:r>
           </a:p>
         </p:txBody>
       </p:sp>
@@ -3953,10 +4082,161 @@
           </a:fontRef>
         </p:style>
         <p:txBody>
-          <a:bodyPr rtlCol="0" anchor="ctr"/>
-          <a:lstStyle/>
-          <a:p>
-            <a:pPr algn="ctr"/>
+          <a:bodyPr rtlCol="0" anchor="t" wrap="none" lIns="0" rIns="0" tIns="325120" bIns="0"/>
+          <a:lstStyle/>
+          <a:p>
+            <a:pPr algn="ctr">
+              <a:lnSpc>
+                <a:spcPts val="1152"/>
+              </a:lnSpc>
+              <a:spcBef>
+                <a:spcPts val="0"/>
+              </a:spcBef>
+              <a:spcAft>
+                <a:spcPts val="0"/>
+              </a:spcAft>
+            </a:pPr>
+            <a:r>
+              <a:rPr sz="1200" b="1">
+                <a:solidFill>
+                  <a:srgbClr val="6E899D"/>
+                </a:solidFill>
+                <a:latin typeface="Arial"/>
+              </a:rPr>
+              <a:t>02</a:t>
+            </a:r>
+          </a:p>
+          <a:p>
+            <a:pPr algn="ctr">
+              <a:lnSpc>
+                <a:spcPts val="1632"/>
+              </a:lnSpc>
+              <a:spcBef>
+                <a:spcPts val="6928"/>
+              </a:spcBef>
+              <a:spcAft>
+                <a:spcPts val="0"/>
+              </a:spcAft>
+            </a:pPr>
+            <a:r>
+              <a:rPr sz="1700" b="1">
+                <a:solidFill>
+                  <a:srgbClr val="15334A"/>
+                </a:solidFill>
+                <a:latin typeface="Arial"/>
+              </a:rPr>
+              <a:t>Feature</a:t>
+            </a:r>
+          </a:p>
+          <a:p>
+            <a:pPr algn="ctr">
+              <a:lnSpc>
+                <a:spcPts val="1632"/>
+              </a:lnSpc>
+              <a:spcBef>
+                <a:spcPts val="128"/>
+              </a:spcBef>
+              <a:spcAft>
+                <a:spcPts val="0"/>
+              </a:spcAft>
+            </a:pPr>
+            <a:r>
+              <a:rPr sz="1700" b="1">
+                <a:solidFill>
+                  <a:srgbClr val="15334A"/>
+                </a:solidFill>
+                <a:latin typeface="Arial"/>
+              </a:rPr>
+              <a:t>processing</a:t>
+            </a:r>
+          </a:p>
+          <a:p>
+            <a:pPr algn="ctr">
+              <a:lnSpc>
+                <a:spcPts val="1344"/>
+              </a:lnSpc>
+              <a:spcBef>
+                <a:spcPts val="1568"/>
+              </a:spcBef>
+              <a:spcAft>
+                <a:spcPts val="0"/>
+              </a:spcAft>
+            </a:pPr>
+            <a:r>
+              <a:rPr sz="1400">
+                <a:solidFill>
+                  <a:srgbClr val="557085"/>
+                </a:solidFill>
+                <a:latin typeface="Arial"/>
+              </a:rPr>
+              <a:t>Normalize, encode</a:t>
+            </a:r>
+          </a:p>
+          <a:p>
+            <a:pPr algn="ctr">
+              <a:lnSpc>
+                <a:spcPts val="1344"/>
+              </a:lnSpc>
+              <a:spcBef>
+                <a:spcPts val="336"/>
+              </a:spcBef>
+              <a:spcAft>
+                <a:spcPts val="0"/>
+              </a:spcAft>
+            </a:pPr>
+            <a:r>
+              <a:rPr sz="1400">
+                <a:solidFill>
+                  <a:srgbClr val="557085"/>
+                </a:solidFill>
+                <a:latin typeface="Arial"/>
+              </a:rPr>
+              <a:t>and split</a:t>
+            </a:r>
+          </a:p>
+          <a:p>
+            <a:pPr algn="ctr">
+              <a:lnSpc>
+                <a:spcPts val="960"/>
+              </a:lnSpc>
+              <a:spcBef>
+                <a:spcPts val="2336"/>
+              </a:spcBef>
+              <a:spcAft>
+                <a:spcPts val="0"/>
+              </a:spcAft>
+            </a:pPr>
+            <a:r>
+              <a:rPr sz="1000" b="1">
+                <a:solidFill>
+                  <a:srgbClr val="7892A4"/>
+                </a:solidFill>
+                <a:latin typeface="Arial"/>
+              </a:rPr>
+              <a:t>OUTPUT</a:t>
+            </a:r>
+          </a:p>
+          <a:p>
+            <a:pPr algn="r">
+              <a:lnSpc>
+                <a:spcPts val="1056"/>
+              </a:lnSpc>
+              <a:spcBef>
+                <a:spcPts val="0"/>
+              </a:spcBef>
+              <a:spcAft>
+                <a:spcPts val="0"/>
+              </a:spcAft>
+            </a:pPr>
+            <a:r>
+              <a:rPr sz="1100" b="1">
+                <a:solidFill>
+                  <a:srgbClr val="4F9A9A"/>
+                </a:solidFill>
+                <a:latin typeface="Arial"/>
+              </a:rPr>
+              <a:t>FEATURE SET</a:t>
+            </a:r>
           </a:p>
         </p:txBody>
       </p:sp>
@@ -4228,10 +4508,139 @@
           </a:fontRef>
         </p:style>
         <p:txBody>
-          <a:bodyPr rtlCol="0" anchor="ctr"/>
-          <a:lstStyle/>
-          <a:p>
-            <a:pPr algn="ctr"/>
+          <a:bodyPr rtlCol="0" anchor="t" wrap="none" lIns="0" rIns="0" tIns="325120" bIns="0"/>
+          <a:lstStyle/>
+          <a:p>
+            <a:pPr algn="ctr">
+              <a:lnSpc>
+                <a:spcPts val="1152"/>
+              </a:lnSpc>
+              <a:spcBef>
+                <a:spcPts val="0"/>
+              </a:spcBef>
+              <a:spcAft>
+                <a:spcPts val="0"/>
+              </a:spcAft>
+            </a:pPr>
+            <a:r>
+              <a:rPr sz="1200" b="1">
+                <a:solidFill>
+                  <a:srgbClr val="6E899D"/>
+                </a:solidFill>
+                <a:latin typeface="Arial"/>
+              </a:rPr>
+              <a:t>03</a:t>
+            </a:r>
+          </a:p>
+          <a:p>
+            <a:pPr algn="ctr">
+              <a:lnSpc>
+                <a:spcPts val="1728"/>
+              </a:lnSpc>
+              <a:spcBef>
+                <a:spcPts val="7328"/>
+              </a:spcBef>
+              <a:spcAft>
+                <a:spcPts val="0"/>
+              </a:spcAft>
+            </a:pPr>
+            <a:r>
+              <a:rPr sz="1800" b="1">
+                <a:solidFill>
+                  <a:srgbClr val="15334A"/>
+                </a:solidFill>
+                <a:latin typeface="Arial"/>
+              </a:rPr>
+              <a:t>Model training</a:t>
+            </a:r>
+          </a:p>
+          <a:p>
+            <a:pPr algn="ctr">
+              <a:lnSpc>
+                <a:spcPts val="1344"/>
+              </a:lnSpc>
+              <a:spcBef>
+                <a:spcPts val="1712"/>
+              </a:spcBef>
+              <a:spcAft>
+                <a:spcPts val="0"/>
+              </a:spcAft>
+            </a:pPr>
+            <a:r>
+              <a:rPr sz="1400">
+                <a:solidFill>
+                  <a:srgbClr val="557085"/>
+                </a:solidFill>
+                <a:latin typeface="Arial"/>
+              </a:rPr>
+              <a:t>Fit model</a:t>
+            </a:r>
+          </a:p>
+          <a:p>
+            <a:pPr algn="ctr">
+              <a:lnSpc>
+                <a:spcPts val="1344"/>
+              </a:lnSpc>
+              <a:spcBef>
+                <a:spcPts val="336"/>
+              </a:spcBef>
+              <a:spcAft>
+                <a:spcPts val="0"/>
+              </a:spcAft>
+            </a:pPr>
+            <a:r>
+              <a:rPr sz="1400">
+                <a:solidFill>
+                  <a:srgbClr val="557085"/>
+                </a:solidFill>
+                <a:latin typeface="Arial"/>
+              </a:rPr>
+              <a:t>parameters</a:t>
+            </a:r>
+          </a:p>
+          <a:p>
+            <a:pPr algn="ctr">
+              <a:lnSpc>
+                <a:spcPts val="960"/>
+              </a:lnSpc>
+              <a:spcBef>
+                <a:spcPts val="3456"/>
+              </a:spcBef>
+              <a:spcAft>
+                <a:spcPts val="0"/>
+              </a:spcAft>
+            </a:pPr>
+            <a:r>
+              <a:rPr sz="1000" b="1">
+                <a:solidFill>
+                  <a:srgbClr val="7892A4"/>
+                </a:solidFill>
+                <a:latin typeface="Arial"/>
+              </a:rPr>
+              <a:t>OUTPUT</a:t>
+            </a:r>
+          </a:p>
+          <a:p>
+            <a:pPr algn="r">
+              <a:lnSpc>
+                <a:spcPts val="1056"/>
+              </a:lnSpc>
+              <a:spcBef>
+                <a:spcPts val="0"/>
+              </a:spcBef>
+              <a:spcAft>
+                <a:spcPts val="0"/>
+              </a:spcAft>
+            </a:pPr>
+            <a:r>
+              <a:rPr sz="1100" b="1">
+                <a:solidFill>
+                  <a:srgbClr val="6C78B7"/>
+                </a:solidFill>
+                <a:latin typeface="Arial"/>
+              </a:rPr>
+              <a:t>MODEL</a:t>
+            </a:r>
           </a:p>
         </p:txBody>
       </p:sp>
@@ -4491,10 +4900,161 @@
           </a:fontRef>
         </p:style>
         <p:txBody>
-          <a:bodyPr rtlCol="0" anchor="ctr"/>
-          <a:lstStyle/>
-          <a:p>
-            <a:pPr algn="ctr"/>
+          <a:bodyPr rtlCol="0" anchor="t" wrap="none" lIns="0" rIns="0" tIns="325120" bIns="0"/>
+          <a:lstStyle/>
+          <a:p>
+            <a:pPr algn="ctr">
+              <a:lnSpc>
+                <a:spcPts val="1152"/>
+              </a:lnSpc>
+              <a:spcBef>
+                <a:spcPts val="0"/>
+              </a:spcBef>
+              <a:spcAft>
+                <a:spcPts val="0"/>
+              </a:spcAft>
+            </a:pPr>
+            <a:r>
+              <a:rPr sz="1200" b="1">
+                <a:solidFill>
+                  <a:srgbClr val="6E899D"/>
+                </a:solidFill>
+                <a:latin typeface="Arial"/>
+              </a:rPr>
+              <a:t>04</a:t>
+            </a:r>
+          </a:p>
+          <a:p>
+            <a:pPr algn="ctr">
+              <a:lnSpc>
+                <a:spcPts val="1632"/>
+              </a:lnSpc>
+              <a:spcBef>
+                <a:spcPts val="6928"/>
+              </a:spcBef>
+              <a:spcAft>
+                <a:spcPts val="0"/>
+              </a:spcAft>
+            </a:pPr>
+            <a:r>
+              <a:rPr sz="1700" b="1">
+                <a:solidFill>
+                  <a:srgbClr val="15334A"/>
+                </a:solidFill>
+                <a:latin typeface="Arial"/>
+              </a:rPr>
+              <a:t>Evaluation</a:t>
+            </a:r>
+          </a:p>
+          <a:p>
+            <a:pPr algn="ctr">
+              <a:lnSpc>
+                <a:spcPts val="1632"/>
+              </a:lnSpc>
+              <a:spcBef>
+                <a:spcPts val="128"/>
+              </a:spcBef>
+              <a:spcAft>
+                <a:spcPts val="0"/>
+              </a:spcAft>
+            </a:pPr>
+            <a:r>
+              <a:rPr sz="1700" b="1">
+                <a:solidFill>
+                  <a:srgbClr val="15334A"/>
+                </a:solidFill>
+                <a:latin typeface="Arial"/>
+              </a:rPr>
+              <a:t>stage</a:t>
+            </a:r>
+          </a:p>
+          <a:p>
+            <a:pPr algn="ctr">
+              <a:lnSpc>
+                <a:spcPts val="1344"/>
+              </a:lnSpc>
+              <a:spcBef>
+                <a:spcPts val="1568"/>
+              </a:spcBef>
+              <a:spcAft>
+                <a:spcPts val="0"/>
+              </a:spcAft>
+            </a:pPr>
+            <a:r>
+              <a:rPr sz="1400">
+                <a:solidFill>
+                  <a:srgbClr val="557085"/>
+                </a:solidFill>
+                <a:latin typeface="Arial"/>
+              </a:rPr>
+              <a:t>Holdout</a:t>
+            </a:r>
+          </a:p>
+          <a:p>
+            <a:pPr algn="ctr">
+              <a:lnSpc>
+                <a:spcPts val="1344"/>
+              </a:lnSpc>
+              <a:spcBef>
+                <a:spcPts val="336"/>
+              </a:spcBef>
+              <a:spcAft>
+                <a:spcPts val="0"/>
+              </a:spcAft>
+            </a:pPr>
+            <a:r>
+              <a:rPr sz="1400">
+                <a:solidFill>
+                  <a:srgbClr val="557085"/>
+                </a:solidFill>
+                <a:latin typeface="Arial"/>
+              </a:rPr>
+              <a:t>metrics</a:t>
+            </a:r>
+          </a:p>
+          <a:p>
+            <a:pPr algn="ctr">
+              <a:lnSpc>
+                <a:spcPts val="960"/>
+              </a:lnSpc>
+              <a:spcBef>
+                <a:spcPts val="2336"/>
+              </a:spcBef>
+              <a:spcAft>
+                <a:spcPts val="0"/>
+              </a:spcAft>
+            </a:pPr>
+            <a:r>
+              <a:rPr sz="1000" b="1">
+                <a:solidFill>
+                  <a:srgbClr val="7892A4"/>
+                </a:solidFill>
+                <a:latin typeface="Arial"/>
+              </a:rPr>
+              <a:t>OUTPUT</a:t>
+            </a:r>
+          </a:p>
+          <a:p>
+            <a:pPr algn="r">
+              <a:lnSpc>
+                <a:spcPts val="1056"/>
+              </a:lnSpc>
+              <a:spcBef>
+                <a:spcPts val="0"/>
+              </a:spcBef>
+              <a:spcAft>
+                <a:spcPts val="0"/>
+              </a:spcAft>
+            </a:pPr>
+            <a:r>
+              <a:rPr sz="1100" b="1">
+                <a:solidFill>
+                  <a:srgbClr val="C18A4A"/>
+                </a:solidFill>
+                <a:latin typeface="Arial"/>
+              </a:rPr>
+              <a:t>METRICS</a:t>
+            </a:r>
           </a:p>
         </p:txBody>
       </p:sp>
@@ -4754,10 +5314,51 @@
           </a:fontRef>
         </p:style>
         <p:txBody>
-          <a:bodyPr rtlCol="0" anchor="ctr"/>
-          <a:lstStyle/>
-          <a:p>
-            <a:pPr algn="ctr"/>
+          <a:bodyPr rtlCol="0" anchor="t" wrap="none" lIns="0" rIns="0" tIns="139700" bIns="0"/>
+          <a:lstStyle/>
+          <a:p>
+            <a:pPr algn="ctr">
+              <a:lnSpc>
+                <a:spcPts val="1056"/>
+              </a:lnSpc>
+              <a:spcBef>
+                <a:spcPts val="0"/>
+              </a:spcBef>
+              <a:spcAft>
+                <a:spcPts val="0"/>
+              </a:spcAft>
+            </a:pPr>
+            <a:r>
+              <a:rPr sz="1100" b="1">
+                <a:solidFill>
+                  <a:srgbClr val="15334A"/>
+                </a:solidFill>
+                <a:latin typeface="Arial"/>
+              </a:rPr>
+              <a:t>HUMAN REVIEW</a:t>
+            </a:r>
+          </a:p>
+          <a:p>
+            <a:pPr algn="ctr">
+              <a:lnSpc>
+                <a:spcPts val="960"/>
+              </a:lnSpc>
+              <a:spcBef>
+                <a:spcPts val="224"/>
+              </a:spcBef>
+              <a:spcAft>
+                <a:spcPts val="0"/>
+              </a:spcAft>
+            </a:pPr>
+            <a:r>
+              <a:rPr sz="1000">
+                <a:solidFill>
+                  <a:srgbClr val="8B6840"/>
+                </a:solidFill>
+                <a:latin typeface="Arial"/>
+              </a:rPr>
+              <a:t>Approve or return</a:t>
+            </a:r>
           </a:p>
         </p:txBody>
       </p:sp>
@@ -5314,10 +5915,139 @@
           </a:fontRef>
         </p:style>
         <p:txBody>
-          <a:bodyPr rtlCol="0" anchor="ctr"/>
-          <a:lstStyle/>
-          <a:p>
-            <a:pPr algn="ctr"/>
+          <a:bodyPr rtlCol="0" anchor="t" wrap="none" lIns="0" rIns="0" tIns="325120" bIns="0"/>
+          <a:lstStyle/>
+          <a:p>
+            <a:pPr algn="ctr">
+              <a:lnSpc>
+                <a:spcPts val="1152"/>
+              </a:lnSpc>
+              <a:spcBef>
+                <a:spcPts val="0"/>
+              </a:spcBef>
+              <a:spcAft>
+                <a:spcPts val="0"/>
+              </a:spcAft>
+            </a:pPr>
+            <a:r>
+              <a:rPr sz="1200" b="1">
+                <a:solidFill>
+                  <a:srgbClr val="6E899D"/>
+                </a:solidFill>
+                <a:latin typeface="Arial"/>
+              </a:rPr>
+              <a:t>05</a:t>
+            </a:r>
+          </a:p>
+          <a:p>
+            <a:pPr algn="ctr">
+              <a:lnSpc>
+                <a:spcPts val="1728"/>
+              </a:lnSpc>
+              <a:spcBef>
+                <a:spcPts val="7328"/>
+              </a:spcBef>
+              <a:spcAft>
+                <a:spcPts val="0"/>
+              </a:spcAft>
+            </a:pPr>
+            <a:r>
+              <a:rPr sz="1800" b="1">
+                <a:solidFill>
+                  <a:srgbClr val="15334A"/>
+                </a:solidFill>
+                <a:latin typeface="Arial"/>
+              </a:rPr>
+              <a:t>Publishing</a:t>
+            </a:r>
+          </a:p>
+          <a:p>
+            <a:pPr algn="ctr">
+              <a:lnSpc>
+                <a:spcPts val="1344"/>
+              </a:lnSpc>
+              <a:spcBef>
+                <a:spcPts val="1712"/>
+              </a:spcBef>
+              <a:spcAft>
+                <a:spcPts val="0"/>
+              </a:spcAft>
+            </a:pPr>
+            <a:r>
+              <a:rPr sz="1400">
+                <a:solidFill>
+                  <a:srgbClr val="557085"/>
+                </a:solidFill>
+                <a:latin typeface="Arial"/>
+              </a:rPr>
+              <a:t>Versioned model</a:t>
+            </a:r>
+          </a:p>
+          <a:p>
+            <a:pPr algn="ctr">
+              <a:lnSpc>
+                <a:spcPts val="1344"/>
+              </a:lnSpc>
+              <a:spcBef>
+                <a:spcPts val="336"/>
+              </a:spcBef>
+              <a:spcAft>
+                <a:spcPts val="0"/>
+              </a:spcAft>
+            </a:pPr>
+            <a:r>
+              <a:rPr sz="1400">
+                <a:solidFill>
+                  <a:srgbClr val="557085"/>
+                </a:solidFill>
+                <a:latin typeface="Arial"/>
+              </a:rPr>
+              <a:t>artifact</a:t>
+            </a:r>
+          </a:p>
+          <a:p>
+            <a:pPr algn="ctr">
+              <a:lnSpc>
+                <a:spcPts val="960"/>
+              </a:lnSpc>
+              <a:spcBef>
+                <a:spcPts val="3456"/>
+              </a:spcBef>
+              <a:spcAft>
+                <a:spcPts val="0"/>
+              </a:spcAft>
+            </a:pPr>
+            <a:r>
+              <a:rPr sz="1000" b="1">
+                <a:solidFill>
+                  <a:srgbClr val="7892A4"/>
+                </a:solidFill>
+                <a:latin typeface="Arial"/>
+              </a:rPr>
+              <a:t>OUTPUT</a:t>
+            </a:r>
+          </a:p>
+          <a:p>
+            <a:pPr algn="r">
+              <a:lnSpc>
+                <a:spcPts val="1056"/>
+              </a:lnSpc>
+              <a:spcBef>
+                <a:spcPts val="0"/>
+              </a:spcBef>
+              <a:spcAft>
+                <a:spcPts val="0"/>
+              </a:spcAft>
+            </a:pPr>
+            <a:r>
+              <a:rPr sz="1100" b="1">
+                <a:solidFill>
+                  <a:srgbClr val="577E68"/>
+                </a:solidFill>
+                <a:latin typeface="Arial"/>
+              </a:rPr>
+              <a:t>ARTIFACT</a:t>
+            </a:r>
           </a:p>
         </p:txBody>
       </p:sp>
@@ -5748,986 +6478,6 @@
         </p:nvSpPr>
         <p:spPr>
           <a:xfrm>
-            <a:off x="711200" y="2387600"/>
-            <a:ext cx="402336" cy="158496"/>
-          </a:xfrm>
-          <a:prstGeom prst="rect">
-            <a:avLst/>
-          </a:prstGeom>
-          <a:noFill/>
-        </p:spPr>
-        <p:txBody>
-          <a:bodyPr wrap="none" tIns="0" bIns="0" lIns="0" rIns="0">
-            <a:spAutoFit/>
-          </a:bodyPr>
-          <a:lstStyle/>
-          <a:p>
-            <a:pPr algn="l"/>
-            <a:r>
-              <a:rPr sz="1200" b="1">
-                <a:solidFill>
-                  <a:srgbClr val="6E899D"/>
-                </a:solidFill>
-                <a:latin typeface="Arial"/>
-              </a:rPr>
-              <a:t>01</a:t>
-            </a:r>
-          </a:p>
-        </p:txBody>
-      </p:sp>
-      <p:sp>
-        <p:nvSpPr>
-          <p:cNvPr id="53" name="TextBox 52"/>
-          <p:cNvSpPr txBox="1"/>
-          <p:nvPr/>
-        </p:nvSpPr>
-        <p:spPr>
-          <a:xfrm>
-            <a:off x="711200" y="3418840"/>
-            <a:ext cx="1670304" cy="237744"/>
-          </a:xfrm>
-          <a:prstGeom prst="rect">
-            <a:avLst/>
-          </a:prstGeom>
-          <a:noFill/>
-        </p:spPr>
-        <p:txBody>
-          <a:bodyPr wrap="none" tIns="0" bIns="0" lIns="0" rIns="0">
-            <a:spAutoFit/>
-          </a:bodyPr>
-          <a:lstStyle/>
-          <a:p>
-            <a:pPr algn="l"/>
-            <a:r>
-              <a:rPr sz="1800" b="1">
-                <a:solidFill>
-                  <a:srgbClr val="15334A"/>
-                </a:solidFill>
-                <a:latin typeface="Arial"/>
-              </a:rPr>
-              <a:t>Data sources</a:t>
-            </a:r>
-          </a:p>
-        </p:txBody>
-      </p:sp>
-      <p:sp>
-        <p:nvSpPr>
-          <p:cNvPr id="54" name="TextBox 53"/>
-          <p:cNvSpPr txBox="1"/>
-          <p:nvPr/>
-        </p:nvSpPr>
-        <p:spPr>
-          <a:xfrm>
-            <a:off x="711200" y="3886200"/>
-            <a:ext cx="1353312" cy="184912"/>
-          </a:xfrm>
-          <a:prstGeom prst="rect">
-            <a:avLst/>
-          </a:prstGeom>
-          <a:noFill/>
-        </p:spPr>
-        <p:txBody>
-          <a:bodyPr wrap="none" tIns="0" bIns="0" lIns="0" rIns="0">
-            <a:spAutoFit/>
-          </a:bodyPr>
-          <a:lstStyle/>
-          <a:p>
-            <a:pPr algn="l"/>
-            <a:r>
-              <a:rPr sz="1400">
-                <a:solidFill>
-                  <a:srgbClr val="557085"/>
-                </a:solidFill>
-                <a:latin typeface="Arial"/>
-              </a:rPr>
-              <a:t>Raw inputs &amp;</a:t>
-            </a:r>
-          </a:p>
-        </p:txBody>
-      </p:sp>
-      <p:sp>
-        <p:nvSpPr>
-          <p:cNvPr id="55" name="TextBox 54"/>
-          <p:cNvSpPr txBox="1"/>
-          <p:nvPr/>
-        </p:nvSpPr>
-        <p:spPr>
-          <a:xfrm>
-            <a:off x="711200" y="4099560"/>
-            <a:ext cx="983488" cy="184912"/>
-          </a:xfrm>
-          <a:prstGeom prst="rect">
-            <a:avLst/>
-          </a:prstGeom>
-          <a:noFill/>
-        </p:spPr>
-        <p:txBody>
-          <a:bodyPr wrap="none" tIns="0" bIns="0" lIns="0" rIns="0">
-            <a:spAutoFit/>
-          </a:bodyPr>
-          <a:lstStyle/>
-          <a:p>
-            <a:pPr algn="l"/>
-            <a:r>
-              <a:rPr sz="1400">
-                <a:solidFill>
-                  <a:srgbClr val="557085"/>
-                </a:solidFill>
-                <a:latin typeface="Arial"/>
-              </a:rPr>
-              <a:t>metadata</a:t>
-            </a:r>
-          </a:p>
-        </p:txBody>
-      </p:sp>
-      <p:sp>
-        <p:nvSpPr>
-          <p:cNvPr id="56" name="TextBox 55"/>
-          <p:cNvSpPr txBox="1"/>
-          <p:nvPr/>
-        </p:nvSpPr>
-        <p:spPr>
-          <a:xfrm>
-            <a:off x="711200" y="4739640"/>
-            <a:ext cx="640080" cy="132080"/>
-          </a:xfrm>
-          <a:prstGeom prst="rect">
-            <a:avLst/>
-          </a:prstGeom>
-          <a:noFill/>
-        </p:spPr>
-        <p:txBody>
-          <a:bodyPr wrap="none" tIns="0" bIns="0" lIns="0" rIns="0">
-            <a:spAutoFit/>
-          </a:bodyPr>
-          <a:lstStyle/>
-          <a:p>
-            <a:pPr algn="l"/>
-            <a:r>
-              <a:rPr sz="1000" b="1">
-                <a:solidFill>
-                  <a:srgbClr val="7892A4"/>
-                </a:solidFill>
-                <a:latin typeface="Arial"/>
-              </a:rPr>
-              <a:t>OUTPUT</a:t>
-            </a:r>
-          </a:p>
-        </p:txBody>
-      </p:sp>
-      <p:sp>
-        <p:nvSpPr>
-          <p:cNvPr id="57" name="TextBox 56"/>
-          <p:cNvSpPr txBox="1"/>
-          <p:nvPr/>
-        </p:nvSpPr>
-        <p:spPr>
-          <a:xfrm>
-            <a:off x="1421892" y="4732020"/>
-            <a:ext cx="752348" cy="145288"/>
-          </a:xfrm>
-          <a:prstGeom prst="rect">
-            <a:avLst/>
-          </a:prstGeom>
-          <a:noFill/>
-        </p:spPr>
-        <p:txBody>
-          <a:bodyPr wrap="none" tIns="0" bIns="0" lIns="0" rIns="0">
-            <a:spAutoFit/>
-          </a:bodyPr>
-          <a:lstStyle/>
-          <a:p>
-            <a:pPr algn="r"/>
-            <a:r>
-              <a:rPr sz="1100" b="1">
-                <a:solidFill>
-                  <a:srgbClr val="4F86A3"/>
-                </a:solidFill>
-                <a:latin typeface="Arial"/>
-              </a:rPr>
-              <a:t>DATASET</a:t>
-            </a:r>
-          </a:p>
-        </p:txBody>
-      </p:sp>
-      <p:sp>
-        <p:nvSpPr>
-          <p:cNvPr id="58" name="TextBox 57"/>
-          <p:cNvSpPr txBox="1"/>
-          <p:nvPr/>
-        </p:nvSpPr>
-        <p:spPr>
-          <a:xfrm>
-            <a:off x="3027680" y="2387600"/>
-            <a:ext cx="402336" cy="158496"/>
-          </a:xfrm>
-          <a:prstGeom prst="rect">
-            <a:avLst/>
-          </a:prstGeom>
-          <a:noFill/>
-        </p:spPr>
-        <p:txBody>
-          <a:bodyPr wrap="none" tIns="0" bIns="0" lIns="0" rIns="0">
-            <a:spAutoFit/>
-          </a:bodyPr>
-          <a:lstStyle/>
-          <a:p>
-            <a:pPr algn="l"/>
-            <a:r>
-              <a:rPr sz="1200" b="1">
-                <a:solidFill>
-                  <a:srgbClr val="6E899D"/>
-                </a:solidFill>
-                <a:latin typeface="Arial"/>
-              </a:rPr>
-              <a:t>02</a:t>
-            </a:r>
-          </a:p>
-        </p:txBody>
-      </p:sp>
-      <p:sp>
-        <p:nvSpPr>
-          <p:cNvPr id="59" name="TextBox 58"/>
-          <p:cNvSpPr txBox="1"/>
-          <p:nvPr/>
-        </p:nvSpPr>
-        <p:spPr>
-          <a:xfrm>
-            <a:off x="3027680" y="3375660"/>
-            <a:ext cx="1029716" cy="224536"/>
-          </a:xfrm>
-          <a:prstGeom prst="rect">
-            <a:avLst/>
-          </a:prstGeom>
-          <a:noFill/>
-        </p:spPr>
-        <p:txBody>
-          <a:bodyPr wrap="none" tIns="0" bIns="0" lIns="0" rIns="0">
-            <a:spAutoFit/>
-          </a:bodyPr>
-          <a:lstStyle/>
-          <a:p>
-            <a:pPr algn="l"/>
-            <a:r>
-              <a:rPr sz="1700" b="1">
-                <a:solidFill>
-                  <a:srgbClr val="15334A"/>
-                </a:solidFill>
-                <a:latin typeface="Arial"/>
-              </a:rPr>
-              <a:t>Feature</a:t>
-            </a:r>
-          </a:p>
-        </p:txBody>
-      </p:sp>
-      <p:sp>
-        <p:nvSpPr>
-          <p:cNvPr id="60" name="TextBox 59"/>
-          <p:cNvSpPr txBox="1"/>
-          <p:nvPr/>
-        </p:nvSpPr>
-        <p:spPr>
-          <a:xfrm>
-            <a:off x="3027680" y="3599180"/>
-            <a:ext cx="1366520" cy="224536"/>
-          </a:xfrm>
-          <a:prstGeom prst="rect">
-            <a:avLst/>
-          </a:prstGeom>
-          <a:noFill/>
-        </p:spPr>
-        <p:txBody>
-          <a:bodyPr wrap="none" tIns="0" bIns="0" lIns="0" rIns="0">
-            <a:spAutoFit/>
-          </a:bodyPr>
-          <a:lstStyle/>
-          <a:p>
-            <a:pPr algn="l"/>
-            <a:r>
-              <a:rPr sz="1700" b="1">
-                <a:solidFill>
-                  <a:srgbClr val="15334A"/>
-                </a:solidFill>
-                <a:latin typeface="Arial"/>
-              </a:rPr>
-              <a:t>processing</a:t>
-            </a:r>
-          </a:p>
-        </p:txBody>
-      </p:sp>
-      <p:sp>
-        <p:nvSpPr>
-          <p:cNvPr id="61" name="TextBox 60"/>
-          <p:cNvSpPr txBox="1"/>
-          <p:nvPr/>
-        </p:nvSpPr>
-        <p:spPr>
-          <a:xfrm>
-            <a:off x="3027680" y="4028440"/>
-            <a:ext cx="1815592" cy="184912"/>
-          </a:xfrm>
-          <a:prstGeom prst="rect">
-            <a:avLst/>
-          </a:prstGeom>
-          <a:noFill/>
-        </p:spPr>
-        <p:txBody>
-          <a:bodyPr wrap="none" tIns="0" bIns="0" lIns="0" rIns="0">
-            <a:spAutoFit/>
-          </a:bodyPr>
-          <a:lstStyle/>
-          <a:p>
-            <a:pPr algn="l"/>
-            <a:r>
-              <a:rPr sz="1400">
-                <a:solidFill>
-                  <a:srgbClr val="557085"/>
-                </a:solidFill>
-                <a:latin typeface="Arial"/>
-              </a:rPr>
-              <a:t>Normalize, encode</a:t>
-            </a:r>
-          </a:p>
-        </p:txBody>
-      </p:sp>
-      <p:sp>
-        <p:nvSpPr>
-          <p:cNvPr id="62" name="TextBox 61"/>
-          <p:cNvSpPr txBox="1"/>
-          <p:nvPr/>
-        </p:nvSpPr>
-        <p:spPr>
-          <a:xfrm>
-            <a:off x="3027680" y="4241800"/>
-            <a:ext cx="1075944" cy="184912"/>
-          </a:xfrm>
-          <a:prstGeom prst="rect">
-            <a:avLst/>
-          </a:prstGeom>
-          <a:noFill/>
-        </p:spPr>
-        <p:txBody>
-          <a:bodyPr wrap="none" tIns="0" bIns="0" lIns="0" rIns="0">
-            <a:spAutoFit/>
-          </a:bodyPr>
-          <a:lstStyle/>
-          <a:p>
-            <a:pPr algn="l"/>
-            <a:r>
-              <a:rPr sz="1400">
-                <a:solidFill>
-                  <a:srgbClr val="557085"/>
-                </a:solidFill>
-                <a:latin typeface="Arial"/>
-              </a:rPr>
-              <a:t>and split</a:t>
-            </a:r>
-          </a:p>
-        </p:txBody>
-      </p:sp>
-      <p:sp>
-        <p:nvSpPr>
-          <p:cNvPr id="63" name="TextBox 62"/>
-          <p:cNvSpPr txBox="1"/>
-          <p:nvPr/>
-        </p:nvSpPr>
-        <p:spPr>
-          <a:xfrm>
-            <a:off x="3027680" y="4739640"/>
-            <a:ext cx="640080" cy="132080"/>
-          </a:xfrm>
-          <a:prstGeom prst="rect">
-            <a:avLst/>
-          </a:prstGeom>
-          <a:noFill/>
-        </p:spPr>
-        <p:txBody>
-          <a:bodyPr wrap="none" tIns="0" bIns="0" lIns="0" rIns="0">
-            <a:spAutoFit/>
-          </a:bodyPr>
-          <a:lstStyle/>
-          <a:p>
-            <a:pPr algn="l"/>
-            <a:r>
-              <a:rPr sz="1000" b="1">
-                <a:solidFill>
-                  <a:srgbClr val="7892A4"/>
-                </a:solidFill>
-                <a:latin typeface="Arial"/>
-              </a:rPr>
-              <a:t>OUTPUT</a:t>
-            </a:r>
-          </a:p>
-        </p:txBody>
-      </p:sp>
-      <p:sp>
-        <p:nvSpPr>
-          <p:cNvPr id="64" name="TextBox 63"/>
-          <p:cNvSpPr txBox="1"/>
-          <p:nvPr/>
-        </p:nvSpPr>
-        <p:spPr>
-          <a:xfrm>
-            <a:off x="3447796" y="4732020"/>
-            <a:ext cx="1042924" cy="145288"/>
-          </a:xfrm>
-          <a:prstGeom prst="rect">
-            <a:avLst/>
-          </a:prstGeom>
-          <a:noFill/>
-        </p:spPr>
-        <p:txBody>
-          <a:bodyPr wrap="none" tIns="0" bIns="0" lIns="0" rIns="0">
-            <a:spAutoFit/>
-          </a:bodyPr>
-          <a:lstStyle/>
-          <a:p>
-            <a:pPr algn="r"/>
-            <a:r>
-              <a:rPr sz="1100" b="1">
-                <a:solidFill>
-                  <a:srgbClr val="4F9A9A"/>
-                </a:solidFill>
-                <a:latin typeface="Arial"/>
-              </a:rPr>
-              <a:t>FEATURE SET</a:t>
-            </a:r>
-          </a:p>
-        </p:txBody>
-      </p:sp>
-      <p:sp>
-        <p:nvSpPr>
-          <p:cNvPr id="65" name="TextBox 64"/>
-          <p:cNvSpPr txBox="1"/>
-          <p:nvPr/>
-        </p:nvSpPr>
-        <p:spPr>
-          <a:xfrm>
-            <a:off x="5344160" y="2387600"/>
-            <a:ext cx="402336" cy="158496"/>
-          </a:xfrm>
-          <a:prstGeom prst="rect">
-            <a:avLst/>
-          </a:prstGeom>
-          <a:noFill/>
-        </p:spPr>
-        <p:txBody>
-          <a:bodyPr wrap="none" tIns="0" bIns="0" lIns="0" rIns="0">
-            <a:spAutoFit/>
-          </a:bodyPr>
-          <a:lstStyle/>
-          <a:p>
-            <a:pPr algn="l"/>
-            <a:r>
-              <a:rPr sz="1200" b="1">
-                <a:solidFill>
-                  <a:srgbClr val="6E899D"/>
-                </a:solidFill>
-                <a:latin typeface="Arial"/>
-              </a:rPr>
-              <a:t>03</a:t>
-            </a:r>
-          </a:p>
-        </p:txBody>
-      </p:sp>
-      <p:sp>
-        <p:nvSpPr>
-          <p:cNvPr id="66" name="TextBox 65"/>
-          <p:cNvSpPr txBox="1"/>
-          <p:nvPr/>
-        </p:nvSpPr>
-        <p:spPr>
-          <a:xfrm>
-            <a:off x="5344160" y="3418840"/>
-            <a:ext cx="1908048" cy="237744"/>
-          </a:xfrm>
-          <a:prstGeom prst="rect">
-            <a:avLst/>
-          </a:prstGeom>
-          <a:noFill/>
-        </p:spPr>
-        <p:txBody>
-          <a:bodyPr wrap="none" tIns="0" bIns="0" lIns="0" rIns="0">
-            <a:spAutoFit/>
-          </a:bodyPr>
-          <a:lstStyle/>
-          <a:p>
-            <a:pPr algn="l"/>
-            <a:r>
-              <a:rPr sz="1800" b="1">
-                <a:solidFill>
-                  <a:srgbClr val="15334A"/>
-                </a:solidFill>
-                <a:latin typeface="Arial"/>
-              </a:rPr>
-              <a:t>Model training</a:t>
-            </a:r>
-          </a:p>
-        </p:txBody>
-      </p:sp>
-      <p:sp>
-        <p:nvSpPr>
-          <p:cNvPr id="67" name="TextBox 66"/>
-          <p:cNvSpPr txBox="1"/>
-          <p:nvPr/>
-        </p:nvSpPr>
-        <p:spPr>
-          <a:xfrm>
-            <a:off x="5344160" y="3886200"/>
-            <a:ext cx="1075944" cy="184912"/>
-          </a:xfrm>
-          <a:prstGeom prst="rect">
-            <a:avLst/>
-          </a:prstGeom>
-          <a:noFill/>
-        </p:spPr>
-        <p:txBody>
-          <a:bodyPr wrap="none" tIns="0" bIns="0" lIns="0" rIns="0">
-            <a:spAutoFit/>
-          </a:bodyPr>
-          <a:lstStyle/>
-          <a:p>
-            <a:pPr algn="l"/>
-            <a:r>
-              <a:rPr sz="1400">
-                <a:solidFill>
-                  <a:srgbClr val="557085"/>
-                </a:solidFill>
-                <a:latin typeface="Arial"/>
-              </a:rPr>
-              <a:t>Fit model</a:t>
-            </a:r>
-          </a:p>
-        </p:txBody>
-      </p:sp>
-      <p:sp>
-        <p:nvSpPr>
-          <p:cNvPr id="68" name="TextBox 67"/>
-          <p:cNvSpPr txBox="1"/>
-          <p:nvPr/>
-        </p:nvSpPr>
-        <p:spPr>
-          <a:xfrm>
-            <a:off x="5344160" y="4099560"/>
-            <a:ext cx="1168400" cy="184912"/>
-          </a:xfrm>
-          <a:prstGeom prst="rect">
-            <a:avLst/>
-          </a:prstGeom>
-          <a:noFill/>
-        </p:spPr>
-        <p:txBody>
-          <a:bodyPr wrap="none" tIns="0" bIns="0" lIns="0" rIns="0">
-            <a:spAutoFit/>
-          </a:bodyPr>
-          <a:lstStyle/>
-          <a:p>
-            <a:pPr algn="l"/>
-            <a:r>
-              <a:rPr sz="1400">
-                <a:solidFill>
-                  <a:srgbClr val="557085"/>
-                </a:solidFill>
-                <a:latin typeface="Arial"/>
-              </a:rPr>
-              <a:t>parameters</a:t>
-            </a:r>
-          </a:p>
-        </p:txBody>
-      </p:sp>
-      <p:sp>
-        <p:nvSpPr>
-          <p:cNvPr id="69" name="TextBox 68"/>
-          <p:cNvSpPr txBox="1"/>
-          <p:nvPr/>
-        </p:nvSpPr>
-        <p:spPr>
-          <a:xfrm>
-            <a:off x="5344160" y="4739640"/>
-            <a:ext cx="640080" cy="132080"/>
-          </a:xfrm>
-          <a:prstGeom prst="rect">
-            <a:avLst/>
-          </a:prstGeom>
-          <a:noFill/>
-        </p:spPr>
-        <p:txBody>
-          <a:bodyPr wrap="none" tIns="0" bIns="0" lIns="0" rIns="0">
-            <a:spAutoFit/>
-          </a:bodyPr>
-          <a:lstStyle/>
-          <a:p>
-            <a:pPr algn="l"/>
-            <a:r>
-              <a:rPr sz="1000" b="1">
-                <a:solidFill>
-                  <a:srgbClr val="7892A4"/>
-                </a:solidFill>
-                <a:latin typeface="Arial"/>
-              </a:rPr>
-              <a:t>OUTPUT</a:t>
-            </a:r>
-          </a:p>
-        </p:txBody>
-      </p:sp>
-      <p:sp>
-        <p:nvSpPr>
-          <p:cNvPr id="70" name="TextBox 69"/>
-          <p:cNvSpPr txBox="1"/>
-          <p:nvPr/>
-        </p:nvSpPr>
-        <p:spPr>
-          <a:xfrm>
-            <a:off x="6200140" y="4732020"/>
-            <a:ext cx="607060" cy="145288"/>
-          </a:xfrm>
-          <a:prstGeom prst="rect">
-            <a:avLst/>
-          </a:prstGeom>
-          <a:noFill/>
-        </p:spPr>
-        <p:txBody>
-          <a:bodyPr wrap="none" tIns="0" bIns="0" lIns="0" rIns="0">
-            <a:spAutoFit/>
-          </a:bodyPr>
-          <a:lstStyle/>
-          <a:p>
-            <a:pPr algn="r"/>
-            <a:r>
-              <a:rPr sz="1100" b="1">
-                <a:solidFill>
-                  <a:srgbClr val="6C78B7"/>
-                </a:solidFill>
-                <a:latin typeface="Arial"/>
-              </a:rPr>
-              <a:t>MODEL</a:t>
-            </a:r>
-          </a:p>
-        </p:txBody>
-      </p:sp>
-      <p:sp>
-        <p:nvSpPr>
-          <p:cNvPr id="71" name="TextBox 70"/>
-          <p:cNvSpPr txBox="1"/>
-          <p:nvPr/>
-        </p:nvSpPr>
-        <p:spPr>
-          <a:xfrm>
-            <a:off x="7660640" y="2387600"/>
-            <a:ext cx="402336" cy="158496"/>
-          </a:xfrm>
-          <a:prstGeom prst="rect">
-            <a:avLst/>
-          </a:prstGeom>
-          <a:noFill/>
-        </p:spPr>
-        <p:txBody>
-          <a:bodyPr wrap="none" tIns="0" bIns="0" lIns="0" rIns="0">
-            <a:spAutoFit/>
-          </a:bodyPr>
-          <a:lstStyle/>
-          <a:p>
-            <a:pPr algn="l"/>
-            <a:r>
-              <a:rPr sz="1200" b="1">
-                <a:solidFill>
-                  <a:srgbClr val="6E899D"/>
-                </a:solidFill>
-                <a:latin typeface="Arial"/>
-              </a:rPr>
-              <a:t>04</a:t>
-            </a:r>
-          </a:p>
-        </p:txBody>
-      </p:sp>
-      <p:sp>
-        <p:nvSpPr>
-          <p:cNvPr id="72" name="TextBox 71"/>
-          <p:cNvSpPr txBox="1"/>
-          <p:nvPr/>
-        </p:nvSpPr>
-        <p:spPr>
-          <a:xfrm>
-            <a:off x="7660640" y="3375660"/>
-            <a:ext cx="1366520" cy="224536"/>
-          </a:xfrm>
-          <a:prstGeom prst="rect">
-            <a:avLst/>
-          </a:prstGeom>
-          <a:noFill/>
-        </p:spPr>
-        <p:txBody>
-          <a:bodyPr wrap="none" tIns="0" bIns="0" lIns="0" rIns="0">
-            <a:spAutoFit/>
-          </a:bodyPr>
-          <a:lstStyle/>
-          <a:p>
-            <a:pPr algn="l"/>
-            <a:r>
-              <a:rPr sz="1700" b="1">
-                <a:solidFill>
-                  <a:srgbClr val="15334A"/>
-                </a:solidFill>
-                <a:latin typeface="Arial"/>
-              </a:rPr>
-              <a:t>Evaluation</a:t>
-            </a:r>
-          </a:p>
-        </p:txBody>
-      </p:sp>
-      <p:sp>
-        <p:nvSpPr>
-          <p:cNvPr id="73" name="TextBox 72"/>
-          <p:cNvSpPr txBox="1"/>
-          <p:nvPr/>
-        </p:nvSpPr>
-        <p:spPr>
-          <a:xfrm>
-            <a:off x="7660640" y="3599180"/>
-            <a:ext cx="805180" cy="224536"/>
-          </a:xfrm>
-          <a:prstGeom prst="rect">
-            <a:avLst/>
-          </a:prstGeom>
-          <a:noFill/>
-        </p:spPr>
-        <p:txBody>
-          <a:bodyPr wrap="none" tIns="0" bIns="0" lIns="0" rIns="0">
-            <a:spAutoFit/>
-          </a:bodyPr>
-          <a:lstStyle/>
-          <a:p>
-            <a:pPr algn="l"/>
-            <a:r>
-              <a:rPr sz="1700" b="1">
-                <a:solidFill>
-                  <a:srgbClr val="15334A"/>
-                </a:solidFill>
-                <a:latin typeface="Arial"/>
-              </a:rPr>
-              <a:t>stage</a:t>
-            </a:r>
-          </a:p>
-        </p:txBody>
-      </p:sp>
-      <p:sp>
-        <p:nvSpPr>
-          <p:cNvPr id="74" name="TextBox 73"/>
-          <p:cNvSpPr txBox="1"/>
-          <p:nvPr/>
-        </p:nvSpPr>
-        <p:spPr>
-          <a:xfrm>
-            <a:off x="7660640" y="4028440"/>
-            <a:ext cx="891032" cy="184912"/>
-          </a:xfrm>
-          <a:prstGeom prst="rect">
-            <a:avLst/>
-          </a:prstGeom>
-          <a:noFill/>
-        </p:spPr>
-        <p:txBody>
-          <a:bodyPr wrap="none" tIns="0" bIns="0" lIns="0" rIns="0">
-            <a:spAutoFit/>
-          </a:bodyPr>
-          <a:lstStyle/>
-          <a:p>
-            <a:pPr algn="l"/>
-            <a:r>
-              <a:rPr sz="1400">
-                <a:solidFill>
-                  <a:srgbClr val="557085"/>
-                </a:solidFill>
-                <a:latin typeface="Arial"/>
-              </a:rPr>
-              <a:t>Holdout</a:t>
-            </a:r>
-          </a:p>
-        </p:txBody>
-      </p:sp>
-      <p:sp>
-        <p:nvSpPr>
-          <p:cNvPr id="75" name="TextBox 74"/>
-          <p:cNvSpPr txBox="1"/>
-          <p:nvPr/>
-        </p:nvSpPr>
-        <p:spPr>
-          <a:xfrm>
-            <a:off x="7660640" y="4241800"/>
-            <a:ext cx="891032" cy="184912"/>
-          </a:xfrm>
-          <a:prstGeom prst="rect">
-            <a:avLst/>
-          </a:prstGeom>
-          <a:noFill/>
-        </p:spPr>
-        <p:txBody>
-          <a:bodyPr wrap="none" tIns="0" bIns="0" lIns="0" rIns="0">
-            <a:spAutoFit/>
-          </a:bodyPr>
-          <a:lstStyle/>
-          <a:p>
-            <a:pPr algn="l"/>
-            <a:r>
-              <a:rPr sz="1400">
-                <a:solidFill>
-                  <a:srgbClr val="557085"/>
-                </a:solidFill>
-                <a:latin typeface="Arial"/>
-              </a:rPr>
-              <a:t>metrics</a:t>
-            </a:r>
-          </a:p>
-        </p:txBody>
-      </p:sp>
-      <p:sp>
-        <p:nvSpPr>
-          <p:cNvPr id="76" name="TextBox 75"/>
-          <p:cNvSpPr txBox="1"/>
-          <p:nvPr/>
-        </p:nvSpPr>
-        <p:spPr>
-          <a:xfrm>
-            <a:off x="7660640" y="4739640"/>
-            <a:ext cx="640080" cy="132080"/>
-          </a:xfrm>
-          <a:prstGeom prst="rect">
-            <a:avLst/>
-          </a:prstGeom>
-          <a:noFill/>
-        </p:spPr>
-        <p:txBody>
-          <a:bodyPr wrap="none" tIns="0" bIns="0" lIns="0" rIns="0">
-            <a:spAutoFit/>
-          </a:bodyPr>
-          <a:lstStyle/>
-          <a:p>
-            <a:pPr algn="l"/>
-            <a:r>
-              <a:rPr sz="1000" b="1">
-                <a:solidFill>
-                  <a:srgbClr val="7892A4"/>
-                </a:solidFill>
-                <a:latin typeface="Arial"/>
-              </a:rPr>
-              <a:t>OUTPUT</a:t>
-            </a:r>
-          </a:p>
-        </p:txBody>
-      </p:sp>
-      <p:sp>
-        <p:nvSpPr>
-          <p:cNvPr id="77" name="TextBox 76"/>
-          <p:cNvSpPr txBox="1"/>
-          <p:nvPr/>
-        </p:nvSpPr>
-        <p:spPr>
-          <a:xfrm>
-            <a:off x="8371332" y="4732020"/>
-            <a:ext cx="752348" cy="145288"/>
-          </a:xfrm>
-          <a:prstGeom prst="rect">
-            <a:avLst/>
-          </a:prstGeom>
-          <a:noFill/>
-        </p:spPr>
-        <p:txBody>
-          <a:bodyPr wrap="none" tIns="0" bIns="0" lIns="0" rIns="0">
-            <a:spAutoFit/>
-          </a:bodyPr>
-          <a:lstStyle/>
-          <a:p>
-            <a:pPr algn="r"/>
-            <a:r>
-              <a:rPr sz="1100" b="1">
-                <a:solidFill>
-                  <a:srgbClr val="C18A4A"/>
-                </a:solidFill>
-                <a:latin typeface="Arial"/>
-              </a:rPr>
-              <a:t>METRICS</a:t>
-            </a:r>
-          </a:p>
-        </p:txBody>
-      </p:sp>
-      <p:sp>
-        <p:nvSpPr>
-          <p:cNvPr id="78" name="TextBox 77"/>
-          <p:cNvSpPr txBox="1"/>
-          <p:nvPr/>
-        </p:nvSpPr>
-        <p:spPr>
-          <a:xfrm>
-            <a:off x="7894320" y="1633220"/>
-            <a:ext cx="1115568" cy="145288"/>
-          </a:xfrm>
-          <a:prstGeom prst="rect">
-            <a:avLst/>
-          </a:prstGeom>
-          <a:noFill/>
-        </p:spPr>
-        <p:txBody>
-          <a:bodyPr wrap="none" tIns="0" bIns="0" lIns="0" rIns="0">
-            <a:spAutoFit/>
-          </a:bodyPr>
-          <a:lstStyle/>
-          <a:p>
-            <a:pPr algn="l"/>
-            <a:r>
-              <a:rPr sz="1100" b="1">
-                <a:solidFill>
-                  <a:srgbClr val="15334A"/>
-                </a:solidFill>
-                <a:latin typeface="Arial"/>
-              </a:rPr>
-              <a:t>HUMAN REVIEW</a:t>
-            </a:r>
-          </a:p>
-        </p:txBody>
-      </p:sp>
-      <p:sp>
-        <p:nvSpPr>
-          <p:cNvPr id="79" name="TextBox 78"/>
-          <p:cNvSpPr txBox="1"/>
-          <p:nvPr/>
-        </p:nvSpPr>
-        <p:spPr>
-          <a:xfrm>
-            <a:off x="7894320" y="1803400"/>
-            <a:ext cx="1366520" cy="132080"/>
-          </a:xfrm>
-          <a:prstGeom prst="rect">
-            <a:avLst/>
-          </a:prstGeom>
-          <a:noFill/>
-        </p:spPr>
-        <p:txBody>
-          <a:bodyPr wrap="none" tIns="0" bIns="0" lIns="0" rIns="0">
-            <a:spAutoFit/>
-          </a:bodyPr>
-          <a:lstStyle/>
-          <a:p>
-            <a:pPr algn="l"/>
-            <a:r>
-              <a:rPr sz="1000">
-                <a:solidFill>
-                  <a:srgbClr val="8B6840"/>
-                </a:solidFill>
-                <a:latin typeface="Arial"/>
-              </a:rPr>
-              <a:t>Approve or return</a:t>
-            </a:r>
-          </a:p>
-        </p:txBody>
-      </p:sp>
-      <p:sp>
-        <p:nvSpPr>
-          <p:cNvPr id="80" name="TextBox 79"/>
-          <p:cNvSpPr txBox="1"/>
-          <p:nvPr/>
-        </p:nvSpPr>
-        <p:spPr>
-          <a:xfrm>
             <a:off x="8870188" y="1577340"/>
             <a:ext cx="659892" cy="118872"/>
           </a:xfrm>
@@ -6757,7 +6507,7 @@
       </p:sp>
       <p:sp>
         <p:nvSpPr>
-          <p:cNvPr id="81" name="TextBox 80"/>
+          <p:cNvPr id="53" name="TextBox 52"/>
           <p:cNvSpPr txBox="1"/>
           <p:nvPr/>
         </p:nvSpPr>
@@ -6792,217 +6542,7 @@
       </p:sp>
       <p:sp>
         <p:nvSpPr>
-          <p:cNvPr id="82" name="TextBox 81"/>
-          <p:cNvSpPr txBox="1"/>
-          <p:nvPr/>
-        </p:nvSpPr>
-        <p:spPr>
-          <a:xfrm>
-            <a:off x="9977120" y="2387600"/>
-            <a:ext cx="402336" cy="158496"/>
-          </a:xfrm>
-          <a:prstGeom prst="rect">
-            <a:avLst/>
-          </a:prstGeom>
-          <a:noFill/>
-        </p:spPr>
-        <p:txBody>
-          <a:bodyPr wrap="none" tIns="0" bIns="0" lIns="0" rIns="0">
-            <a:spAutoFit/>
-          </a:bodyPr>
-          <a:lstStyle/>
-          <a:p>
-            <a:pPr algn="l"/>
-            <a:r>
-              <a:rPr sz="1200" b="1">
-                <a:solidFill>
-                  <a:srgbClr val="6E899D"/>
-                </a:solidFill>
-                <a:latin typeface="Arial"/>
-              </a:rPr>
-              <a:t>05</a:t>
-            </a:r>
-          </a:p>
-        </p:txBody>
-      </p:sp>
-      <p:sp>
-        <p:nvSpPr>
-          <p:cNvPr id="83" name="TextBox 82"/>
-          <p:cNvSpPr txBox="1"/>
-          <p:nvPr/>
-        </p:nvSpPr>
-        <p:spPr>
-          <a:xfrm>
-            <a:off x="9977120" y="3418840"/>
-            <a:ext cx="1432560" cy="237744"/>
-          </a:xfrm>
-          <a:prstGeom prst="rect">
-            <a:avLst/>
-          </a:prstGeom>
-          <a:noFill/>
-        </p:spPr>
-        <p:txBody>
-          <a:bodyPr wrap="none" tIns="0" bIns="0" lIns="0" rIns="0">
-            <a:spAutoFit/>
-          </a:bodyPr>
-          <a:lstStyle/>
-          <a:p>
-            <a:pPr algn="l"/>
-            <a:r>
-              <a:rPr sz="1800" b="1">
-                <a:solidFill>
-                  <a:srgbClr val="15334A"/>
-                </a:solidFill>
-                <a:latin typeface="Arial"/>
-              </a:rPr>
-              <a:t>Publishing</a:t>
-            </a:r>
-          </a:p>
-        </p:txBody>
-      </p:sp>
-      <p:sp>
-        <p:nvSpPr>
-          <p:cNvPr id="84" name="TextBox 83"/>
-          <p:cNvSpPr txBox="1"/>
-          <p:nvPr/>
-        </p:nvSpPr>
-        <p:spPr>
-          <a:xfrm>
-            <a:off x="9977120" y="3886200"/>
-            <a:ext cx="1630680" cy="184912"/>
-          </a:xfrm>
-          <a:prstGeom prst="rect">
-            <a:avLst/>
-          </a:prstGeom>
-          <a:noFill/>
-        </p:spPr>
-        <p:txBody>
-          <a:bodyPr wrap="none" tIns="0" bIns="0" lIns="0" rIns="0">
-            <a:spAutoFit/>
-          </a:bodyPr>
-          <a:lstStyle/>
-          <a:p>
-            <a:pPr algn="l"/>
-            <a:r>
-              <a:rPr sz="1400">
-                <a:solidFill>
-                  <a:srgbClr val="557085"/>
-                </a:solidFill>
-                <a:latin typeface="Arial"/>
-              </a:rPr>
-              <a:t>Versioned model</a:t>
-            </a:r>
-          </a:p>
-        </p:txBody>
-      </p:sp>
-      <p:sp>
-        <p:nvSpPr>
-          <p:cNvPr id="85" name="TextBox 84"/>
-          <p:cNvSpPr txBox="1"/>
-          <p:nvPr/>
-        </p:nvSpPr>
-        <p:spPr>
-          <a:xfrm>
-            <a:off x="9977120" y="4099560"/>
-            <a:ext cx="983488" cy="184912"/>
-          </a:xfrm>
-          <a:prstGeom prst="rect">
-            <a:avLst/>
-          </a:prstGeom>
-          <a:noFill/>
-        </p:spPr>
-        <p:txBody>
-          <a:bodyPr wrap="none" tIns="0" bIns="0" lIns="0" rIns="0">
-            <a:spAutoFit/>
-          </a:bodyPr>
-          <a:lstStyle/>
-          <a:p>
-            <a:pPr algn="l"/>
-            <a:r>
-              <a:rPr sz="1400">
-                <a:solidFill>
-                  <a:srgbClr val="557085"/>
-                </a:solidFill>
-                <a:latin typeface="Arial"/>
-              </a:rPr>
-              <a:t>artifact</a:t>
-            </a:r>
-          </a:p>
-        </p:txBody>
-      </p:sp>
-      <p:sp>
-        <p:nvSpPr>
-          <p:cNvPr id="86" name="TextBox 85"/>
-          <p:cNvSpPr txBox="1"/>
-          <p:nvPr/>
-        </p:nvSpPr>
-        <p:spPr>
-          <a:xfrm>
-            <a:off x="9977120" y="4739640"/>
-            <a:ext cx="640080" cy="132080"/>
-          </a:xfrm>
-          <a:prstGeom prst="rect">
-            <a:avLst/>
-          </a:prstGeom>
-          <a:noFill/>
-        </p:spPr>
-        <p:txBody>
-          <a:bodyPr wrap="none" tIns="0" bIns="0" lIns="0" rIns="0">
-            <a:spAutoFit/>
-          </a:bodyPr>
-          <a:lstStyle/>
-          <a:p>
-            <a:pPr algn="l"/>
-            <a:r>
-              <a:rPr sz="1000" b="1">
-                <a:solidFill>
-                  <a:srgbClr val="7892A4"/>
-                </a:solidFill>
-                <a:latin typeface="Arial"/>
-              </a:rPr>
-              <a:t>OUTPUT</a:t>
-            </a:r>
-          </a:p>
-        </p:txBody>
-      </p:sp>
-      <p:sp>
-        <p:nvSpPr>
-          <p:cNvPr id="87" name="TextBox 86"/>
-          <p:cNvSpPr txBox="1"/>
-          <p:nvPr/>
-        </p:nvSpPr>
-        <p:spPr>
-          <a:xfrm>
-            <a:off x="10655808" y="4732020"/>
-            <a:ext cx="824992" cy="145288"/>
-          </a:xfrm>
-          <a:prstGeom prst="rect">
-            <a:avLst/>
-          </a:prstGeom>
-          <a:noFill/>
-        </p:spPr>
-        <p:txBody>
-          <a:bodyPr wrap="none" tIns="0" bIns="0" lIns="0" rIns="0">
-            <a:spAutoFit/>
-          </a:bodyPr>
-          <a:lstStyle/>
-          <a:p>
-            <a:pPr algn="r"/>
-            <a:r>
-              <a:rPr sz="1100" b="1">
-                <a:solidFill>
-                  <a:srgbClr val="577E68"/>
-                </a:solidFill>
-                <a:latin typeface="Arial"/>
-              </a:rPr>
-              <a:t>ARTIFACT</a:t>
-            </a:r>
-          </a:p>
-        </p:txBody>
-      </p:sp>
-      <p:sp>
-        <p:nvSpPr>
-          <p:cNvPr id="88" name="TextBox 87"/>
+          <p:cNvPr id="54" name="TextBox 53"/>
           <p:cNvSpPr txBox="1"/>
           <p:nvPr/>
         </p:nvSpPr>
@@ -7037,7 +6577,7 @@
       </p:sp>
       <p:sp>
         <p:nvSpPr>
-          <p:cNvPr id="89" name="TextBox 88"/>
+          <p:cNvPr id="55" name="TextBox 54"/>
           <p:cNvSpPr txBox="1"/>
           <p:nvPr/>
         </p:nvSpPr>
@@ -7090,8 +6630,8 @@
       <p:grpSpPr/>
       <p:pic>
         <p:nvPicPr>
-          <p:cNvPr id="35" name="Picture 34" descr="generated.png"/>
-          <p:cNvPicPr>
+          <p:cNvPr id="20" name="Picture 20"/>
+          <p:cNvPicPr preferRelativeResize="0">
             <a:picLocks noChangeAspect="1"/>
           </p:cNvPicPr>
           <p:nvPr/>
@@ -7148,10 +6688,73 @@
           </a:fontRef>
         </p:style>
         <p:txBody>
-          <a:bodyPr rtlCol="0" anchor="ctr"/>
-          <a:lstStyle/>
-          <a:p>
-            <a:pPr algn="ctr"/>
+          <a:bodyPr rtlCol="0" anchor="t" wrap="none" lIns="0" rIns="0" tIns="225552" bIns="0"/>
+          <a:lstStyle/>
+          <a:p>
+            <a:pPr algn="ctr">
+              <a:lnSpc>
+                <a:spcPts val="1152"/>
+              </a:lnSpc>
+              <a:spcBef>
+                <a:spcPts val="0"/>
+              </a:spcBef>
+              <a:spcAft>
+                <a:spcPts val="0"/>
+              </a:spcAft>
+            </a:pPr>
+            <a:r>
+              <a:rPr sz="1200" b="1">
+                <a:solidFill>
+                  <a:srgbClr val="B8DDE2"/>
+                </a:solidFill>
+                <a:latin typeface="Arial"/>
+              </a:rPr>
+              <a:t>RESEARCH COLLABORATION</a:t>
+            </a:r>
+          </a:p>
+          <a:p>
+            <a:pPr algn="ctr">
+              <a:lnSpc>
+                <a:spcPts val="2496"/>
+              </a:lnSpc>
+              <a:spcBef>
+                <a:spcPts val="1648"/>
+              </a:spcBef>
+              <a:spcAft>
+                <a:spcPts val="0"/>
+              </a:spcAft>
+            </a:pPr>
+            <a:r>
+              <a:rPr sz="2600" b="1">
+                <a:solidFill>
+                  <a:srgbClr val="FFFFFF"/>
+                </a:solidFill>
+                <a:latin typeface="Arial"/>
+              </a:rPr>
+              <a:t>Researcher + AI loop</a:t>
+            </a:r>
+          </a:p>
+          <a:p>
+            <a:pPr algn="ctr">
+              <a:lnSpc>
+                <a:spcPts val="1248"/>
+              </a:lnSpc>
+              <a:spcBef>
+                <a:spcPts val="0"/>
+              </a:spcBef>
+              <a:spcAft>
+                <a:spcPts val="0"/>
+              </a:spcAft>
+            </a:pPr>
+            <a:r>
+              <a:rPr sz="1300">
+                <a:solidFill>
+                  <a:srgbClr val="D5E4EA"/>
+                </a:solidFill>
+                <a:latin typeface="Arial"/>
+              </a:rPr>
+              <a:t>Editable annotations sit above the illustrative base.</a:t>
+            </a:r>
           </a:p>
         </p:txBody>
       </p:sp>
@@ -7236,10 +6839,51 @@
           </a:fontRef>
         </p:style>
         <p:txBody>
-          <a:bodyPr rtlCol="0" anchor="ctr"/>
-          <a:lstStyle/>
-          <a:p>
-            <a:pPr algn="ctr"/>
+          <a:bodyPr rtlCol="0" anchor="t" wrap="none" lIns="0" rIns="0" tIns="218440" bIns="0"/>
+          <a:lstStyle/>
+          <a:p>
+            <a:pPr algn="ctr">
+              <a:lnSpc>
+                <a:spcPts val="960"/>
+              </a:lnSpc>
+              <a:spcBef>
+                <a:spcPts val="0"/>
+              </a:spcBef>
+              <a:spcAft>
+                <a:spcPts val="0"/>
+              </a:spcAft>
+            </a:pPr>
+            <a:r>
+              <a:rPr sz="1000" b="1">
+                <a:solidFill>
+                  <a:srgbClr val="6E899D"/>
+                </a:solidFill>
+                <a:latin typeface="Arial"/>
+              </a:rPr>
+              <a:t>EDITABLE COLLABORATION LOOP</a:t>
+            </a:r>
+          </a:p>
+          <a:p>
+            <a:pPr algn="ctr">
+              <a:lnSpc>
+                <a:spcPts val="960"/>
+              </a:lnSpc>
+              <a:spcBef>
+                <a:spcPts val="7040"/>
+              </a:spcBef>
+              <a:spcAft>
+                <a:spcPts val="0"/>
+              </a:spcAft>
+            </a:pPr>
+            <a:r>
+              <a:rPr sz="1000">
+                <a:solidFill>
+                  <a:srgbClr val="7892A4"/>
+                </a:solidFill>
+                <a:latin typeface="Arial"/>
+              </a:rPr>
+              <a:t>Illustrative AI-generated base only • factual callouts remain editable overlays</a:t>
+            </a:r>
           </a:p>
         </p:txBody>
       </p:sp>
@@ -7281,10 +6925,51 @@
           </a:fontRef>
         </p:style>
         <p:txBody>
-          <a:bodyPr rtlCol="0" anchor="ctr"/>
-          <a:lstStyle/>
-          <a:p>
-            <a:pPr algn="ctr"/>
+          <a:bodyPr rtlCol="0" anchor="t" wrap="none" lIns="0" rIns="0" tIns="203200" bIns="0"/>
+          <a:lstStyle/>
+          <a:p>
+            <a:pPr algn="ctr">
+              <a:lnSpc>
+                <a:spcPts val="1152"/>
+              </a:lnSpc>
+              <a:spcBef>
+                <a:spcPts val="0"/>
+              </a:spcBef>
+              <a:spcAft>
+                <a:spcPts val="0"/>
+              </a:spcAft>
+            </a:pPr>
+            <a:r>
+              <a:rPr sz="1200" b="1">
+                <a:solidFill>
+                  <a:srgbClr val="15334A"/>
+                </a:solidFill>
+                <a:latin typeface="Arial"/>
+              </a:rPr>
+              <a:t>RESEARCHER</a:t>
+            </a:r>
+          </a:p>
+          <a:p>
+            <a:pPr algn="ctr">
+              <a:lnSpc>
+                <a:spcPts val="1152"/>
+              </a:lnSpc>
+              <a:spcBef>
+                <a:spcPts val="368"/>
+              </a:spcBef>
+              <a:spcAft>
+                <a:spcPts val="0"/>
+              </a:spcAft>
+            </a:pPr>
+            <a:r>
+              <a:rPr sz="1200">
+                <a:solidFill>
+                  <a:srgbClr val="557085"/>
+                </a:solidFill>
+                <a:latin typeface="Arial"/>
+              </a:rPr>
+              <a:t>Frames the question</a:t>
+            </a:r>
           </a:p>
         </p:txBody>
       </p:sp>
@@ -7441,10 +7126,51 @@
           </a:fontRef>
         </p:style>
         <p:txBody>
-          <a:bodyPr rtlCol="0" anchor="ctr"/>
-          <a:lstStyle/>
-          <a:p>
-            <a:pPr algn="ctr"/>
+          <a:bodyPr rtlCol="0" anchor="t" wrap="none" lIns="0" rIns="0" tIns="203200" bIns="0"/>
+          <a:lstStyle/>
+          <a:p>
+            <a:pPr algn="ctr">
+              <a:lnSpc>
+                <a:spcPts val="1152"/>
+              </a:lnSpc>
+              <a:spcBef>
+                <a:spcPts val="0"/>
+              </a:spcBef>
+              <a:spcAft>
+                <a:spcPts val="0"/>
+              </a:spcAft>
+            </a:pPr>
+            <a:r>
+              <a:rPr sz="1200" b="1">
+                <a:solidFill>
+                  <a:srgbClr val="15334A"/>
+                </a:solidFill>
+                <a:latin typeface="Arial"/>
+              </a:rPr>
+              <a:t>AI LAB</a:t>
+            </a:r>
+          </a:p>
+          <a:p>
+            <a:pPr algn="ctr">
+              <a:lnSpc>
+                <a:spcPts val="1152"/>
+              </a:lnSpc>
+              <a:spcBef>
+                <a:spcPts val="368"/>
+              </a:spcBef>
+              <a:spcAft>
+                <a:spcPts val="0"/>
+              </a:spcAft>
+            </a:pPr>
+            <a:r>
+              <a:rPr sz="1200">
+                <a:solidFill>
+                  <a:srgbClr val="557085"/>
+                </a:solidFill>
+                <a:latin typeface="Arial"/>
+              </a:rPr>
+              <a:t>Surfaces patterns</a:t>
+            </a:r>
           </a:p>
         </p:txBody>
       </p:sp>
@@ -7604,10 +7330,51 @@
           </a:fontRef>
         </p:style>
         <p:txBody>
-          <a:bodyPr rtlCol="0" anchor="ctr"/>
-          <a:lstStyle/>
-          <a:p>
-            <a:pPr algn="ctr"/>
+          <a:bodyPr rtlCol="0" anchor="t" wrap="none" lIns="0" rIns="0" tIns="210820" bIns="0"/>
+          <a:lstStyle/>
+          <a:p>
+            <a:pPr algn="ctr">
+              <a:lnSpc>
+                <a:spcPts val="1056"/>
+              </a:lnSpc>
+              <a:spcBef>
+                <a:spcPts val="0"/>
+              </a:spcBef>
+              <a:spcAft>
+                <a:spcPts val="0"/>
+              </a:spcAft>
+            </a:pPr>
+            <a:r>
+              <a:rPr sz="1100" b="1">
+                <a:solidFill>
+                  <a:srgbClr val="15334A"/>
+                </a:solidFill>
+                <a:latin typeface="Arial"/>
+              </a:rPr>
+              <a:t>QUESTION</a:t>
+            </a:r>
+          </a:p>
+          <a:p>
+            <a:pPr algn="ctr">
+              <a:lnSpc>
+                <a:spcPts val="1056"/>
+              </a:lnSpc>
+              <a:spcBef>
+                <a:spcPts val="464"/>
+              </a:spcBef>
+              <a:spcAft>
+                <a:spcPts val="0"/>
+              </a:spcAft>
+            </a:pPr>
+            <a:r>
+              <a:rPr sz="1100">
+                <a:solidFill>
+                  <a:srgbClr val="557085"/>
+                </a:solidFill>
+                <a:latin typeface="Arial"/>
+              </a:rPr>
+              <a:t>frame</a:t>
+            </a:r>
           </a:p>
         </p:txBody>
       </p:sp>
@@ -7649,10 +7416,51 @@
           </a:fontRef>
         </p:style>
         <p:txBody>
-          <a:bodyPr rtlCol="0" anchor="ctr"/>
-          <a:lstStyle/>
-          <a:p>
-            <a:pPr algn="ctr"/>
+          <a:bodyPr rtlCol="0" anchor="t" wrap="none" lIns="0" rIns="0" tIns="210820" bIns="0"/>
+          <a:lstStyle/>
+          <a:p>
+            <a:pPr algn="ctr">
+              <a:lnSpc>
+                <a:spcPts val="1056"/>
+              </a:lnSpc>
+              <a:spcBef>
+                <a:spcPts val="0"/>
+              </a:spcBef>
+              <a:spcAft>
+                <a:spcPts val="0"/>
+              </a:spcAft>
+            </a:pPr>
+            <a:r>
+              <a:rPr sz="1100" b="1">
+                <a:solidFill>
+                  <a:srgbClr val="15334A"/>
+                </a:solidFill>
+                <a:latin typeface="Arial"/>
+              </a:rPr>
+              <a:t>EXPERIMENT</a:t>
+            </a:r>
+          </a:p>
+          <a:p>
+            <a:pPr algn="ctr">
+              <a:lnSpc>
+                <a:spcPts val="1056"/>
+              </a:lnSpc>
+              <a:spcBef>
+                <a:spcPts val="464"/>
+              </a:spcBef>
+              <a:spcAft>
+                <a:spcPts val="0"/>
+              </a:spcAft>
+            </a:pPr>
+            <a:r>
+              <a:rPr sz="1100">
+                <a:solidFill>
+                  <a:srgbClr val="557085"/>
+                </a:solidFill>
+                <a:latin typeface="Arial"/>
+              </a:rPr>
+              <a:t>probe</a:t>
+            </a:r>
           </a:p>
         </p:txBody>
       </p:sp>
@@ -7694,10 +7502,51 @@
           </a:fontRef>
         </p:style>
         <p:txBody>
-          <a:bodyPr rtlCol="0" anchor="ctr"/>
-          <a:lstStyle/>
-          <a:p>
-            <a:pPr algn="ctr"/>
+          <a:bodyPr rtlCol="0" anchor="t" wrap="none" lIns="0" rIns="0" tIns="210820" bIns="0"/>
+          <a:lstStyle/>
+          <a:p>
+            <a:pPr algn="ctr">
+              <a:lnSpc>
+                <a:spcPts val="1056"/>
+              </a:lnSpc>
+              <a:spcBef>
+                <a:spcPts val="0"/>
+              </a:spcBef>
+              <a:spcAft>
+                <a:spcPts val="0"/>
+              </a:spcAft>
+            </a:pPr>
+            <a:r>
+              <a:rPr sz="1100" b="1">
+                <a:solidFill>
+                  <a:srgbClr val="15334A"/>
+                </a:solidFill>
+                <a:latin typeface="Arial"/>
+              </a:rPr>
+              <a:t>JUDGMENT</a:t>
+            </a:r>
+          </a:p>
+          <a:p>
+            <a:pPr algn="ctr">
+              <a:lnSpc>
+                <a:spcPts val="1056"/>
+              </a:lnSpc>
+              <a:spcBef>
+                <a:spcPts val="464"/>
+              </a:spcBef>
+              <a:spcAft>
+                <a:spcPts val="0"/>
+              </a:spcAft>
+            </a:pPr>
+            <a:r>
+              <a:rPr sz="1100">
+                <a:solidFill>
+                  <a:srgbClr val="8B6840"/>
+                </a:solidFill>
+                <a:latin typeface="Arial"/>
+              </a:rPr>
+              <a:t>review</a:t>
+            </a:r>
           </a:p>
         </p:txBody>
       </p:sp>
@@ -8051,531 +7900,6 @@
           <a:lstStyle/>
           <a:p>
             <a:pPr algn="ctr"/>
-          </a:p>
-        </p:txBody>
-      </p:sp>
-      <p:sp>
-        <p:nvSpPr>
-          <p:cNvPr id="20" name="TextBox 19"/>
-          <p:cNvSpPr txBox="1"/>
-          <p:nvPr/>
-        </p:nvSpPr>
-        <p:spPr>
-          <a:xfrm>
-            <a:off x="711200" y="619760"/>
-            <a:ext cx="1987296" cy="158496"/>
-          </a:xfrm>
-          <a:prstGeom prst="rect">
-            <a:avLst/>
-          </a:prstGeom>
-          <a:noFill/>
-        </p:spPr>
-        <p:txBody>
-          <a:bodyPr wrap="none" tIns="0" bIns="0" lIns="0" rIns="0">
-            <a:spAutoFit/>
-          </a:bodyPr>
-          <a:lstStyle/>
-          <a:p>
-            <a:pPr algn="l"/>
-            <a:r>
-              <a:rPr sz="1200" b="1">
-                <a:solidFill>
-                  <a:srgbClr val="B8DDE2"/>
-                </a:solidFill>
-                <a:latin typeface="Arial"/>
-              </a:rPr>
-              <a:t>RESEARCH COLLABORATION</a:t>
-            </a:r>
-          </a:p>
-        </p:txBody>
-      </p:sp>
-      <p:sp>
-        <p:nvSpPr>
-          <p:cNvPr id="21" name="TextBox 20"/>
-          <p:cNvSpPr txBox="1"/>
-          <p:nvPr/>
-        </p:nvSpPr>
-        <p:spPr>
-          <a:xfrm>
-            <a:off x="711200" y="868680"/>
-            <a:ext cx="3677920" cy="343408"/>
-          </a:xfrm>
-          <a:prstGeom prst="rect">
-            <a:avLst/>
-          </a:prstGeom>
-          <a:noFill/>
-        </p:spPr>
-        <p:txBody>
-          <a:bodyPr wrap="none" tIns="0" bIns="0" lIns="0" rIns="0">
-            <a:spAutoFit/>
-          </a:bodyPr>
-          <a:lstStyle/>
-          <a:p>
-            <a:pPr algn="l"/>
-            <a:r>
-              <a:rPr sz="2600" b="1">
-                <a:solidFill>
-                  <a:srgbClr val="FFFFFF"/>
-                </a:solidFill>
-                <a:latin typeface="Arial"/>
-              </a:rPr>
-              <a:t>Researcher + AI loop</a:t>
-            </a:r>
-          </a:p>
-        </p:txBody>
-      </p:sp>
-      <p:sp>
-        <p:nvSpPr>
-          <p:cNvPr id="22" name="TextBox 21"/>
-          <p:cNvSpPr txBox="1"/>
-          <p:nvPr/>
-        </p:nvSpPr>
-        <p:spPr>
-          <a:xfrm>
-            <a:off x="711200" y="1201420"/>
-            <a:ext cx="4793996" cy="171704"/>
-          </a:xfrm>
-          <a:prstGeom prst="rect">
-            <a:avLst/>
-          </a:prstGeom>
-          <a:noFill/>
-        </p:spPr>
-        <p:txBody>
-          <a:bodyPr wrap="none" tIns="0" bIns="0" lIns="0" rIns="0">
-            <a:spAutoFit/>
-          </a:bodyPr>
-          <a:lstStyle/>
-          <a:p>
-            <a:pPr algn="l"/>
-            <a:r>
-              <a:rPr sz="1300">
-                <a:solidFill>
-                  <a:srgbClr val="D5E4EA"/>
-                </a:solidFill>
-                <a:latin typeface="Arial"/>
-              </a:rPr>
-              <a:t>Editable annotations sit above the illustrative base.</a:t>
-            </a:r>
-          </a:p>
-        </p:txBody>
-      </p:sp>
-      <p:sp>
-        <p:nvSpPr>
-          <p:cNvPr id="23" name="TextBox 22"/>
-          <p:cNvSpPr txBox="1"/>
-          <p:nvPr/>
-        </p:nvSpPr>
-        <p:spPr>
-          <a:xfrm>
-            <a:off x="1137920" y="5425440"/>
-            <a:ext cx="1036320" cy="158496"/>
-          </a:xfrm>
-          <a:prstGeom prst="rect">
-            <a:avLst/>
-          </a:prstGeom>
-          <a:noFill/>
-        </p:spPr>
-        <p:txBody>
-          <a:bodyPr wrap="none" tIns="0" bIns="0" lIns="0" rIns="0">
-            <a:spAutoFit/>
-          </a:bodyPr>
-          <a:lstStyle/>
-          <a:p>
-            <a:pPr algn="l"/>
-            <a:r>
-              <a:rPr sz="1200" b="1">
-                <a:solidFill>
-                  <a:srgbClr val="15334A"/>
-                </a:solidFill>
-                <a:latin typeface="Arial"/>
-              </a:rPr>
-              <a:t>RESEARCHER</a:t>
-            </a:r>
-          </a:p>
-        </p:txBody>
-      </p:sp>
-      <p:sp>
-        <p:nvSpPr>
-          <p:cNvPr id="24" name="TextBox 23"/>
-          <p:cNvSpPr txBox="1"/>
-          <p:nvPr/>
-        </p:nvSpPr>
-        <p:spPr>
-          <a:xfrm>
-            <a:off x="1137920" y="5618480"/>
-            <a:ext cx="1749552" cy="158496"/>
-          </a:xfrm>
-          <a:prstGeom prst="rect">
-            <a:avLst/>
-          </a:prstGeom>
-          <a:noFill/>
-        </p:spPr>
-        <p:txBody>
-          <a:bodyPr wrap="none" tIns="0" bIns="0" lIns="0" rIns="0">
-            <a:spAutoFit/>
-          </a:bodyPr>
-          <a:lstStyle/>
-          <a:p>
-            <a:pPr algn="l"/>
-            <a:r>
-              <a:rPr sz="1200">
-                <a:solidFill>
-                  <a:srgbClr val="557085"/>
-                </a:solidFill>
-                <a:latin typeface="Arial"/>
-              </a:rPr>
-              <a:t>Frames the question</a:t>
-            </a:r>
-          </a:p>
-        </p:txBody>
-      </p:sp>
-      <p:sp>
-        <p:nvSpPr>
-          <p:cNvPr id="25" name="TextBox 24"/>
-          <p:cNvSpPr txBox="1"/>
-          <p:nvPr/>
-        </p:nvSpPr>
-        <p:spPr>
-          <a:xfrm>
-            <a:off x="9489440" y="5425440"/>
-            <a:ext cx="719328" cy="158496"/>
-          </a:xfrm>
-          <a:prstGeom prst="rect">
-            <a:avLst/>
-          </a:prstGeom>
-          <a:noFill/>
-        </p:spPr>
-        <p:txBody>
-          <a:bodyPr wrap="none" tIns="0" bIns="0" lIns="0" rIns="0">
-            <a:spAutoFit/>
-          </a:bodyPr>
-          <a:lstStyle/>
-          <a:p>
-            <a:pPr algn="l"/>
-            <a:r>
-              <a:rPr sz="1200" b="1">
-                <a:solidFill>
-                  <a:srgbClr val="15334A"/>
-                </a:solidFill>
-                <a:latin typeface="Arial"/>
-              </a:rPr>
-              <a:t>AI LAB</a:t>
-            </a:r>
-          </a:p>
-        </p:txBody>
-      </p:sp>
-      <p:sp>
-        <p:nvSpPr>
-          <p:cNvPr id="26" name="TextBox 25"/>
-          <p:cNvSpPr txBox="1"/>
-          <p:nvPr/>
-        </p:nvSpPr>
-        <p:spPr>
-          <a:xfrm>
-            <a:off x="9489440" y="5618480"/>
-            <a:ext cx="1591056" cy="158496"/>
-          </a:xfrm>
-          <a:prstGeom prst="rect">
-            <a:avLst/>
-          </a:prstGeom>
-          <a:noFill/>
-        </p:spPr>
-        <p:txBody>
-          <a:bodyPr wrap="none" tIns="0" bIns="0" lIns="0" rIns="0">
-            <a:spAutoFit/>
-          </a:bodyPr>
-          <a:lstStyle/>
-          <a:p>
-            <a:pPr algn="l"/>
-            <a:r>
-              <a:rPr sz="1200">
-                <a:solidFill>
-                  <a:srgbClr val="557085"/>
-                </a:solidFill>
-                <a:latin typeface="Arial"/>
-              </a:rPr>
-              <a:t>Surfaces patterns</a:t>
-            </a:r>
-          </a:p>
-        </p:txBody>
-      </p:sp>
-      <p:sp>
-        <p:nvSpPr>
-          <p:cNvPr id="27" name="TextBox 26"/>
-          <p:cNvSpPr txBox="1"/>
-          <p:nvPr/>
-        </p:nvSpPr>
-        <p:spPr>
-          <a:xfrm>
-            <a:off x="731520" y="5105400"/>
-            <a:ext cx="2026920" cy="132080"/>
-          </a:xfrm>
-          <a:prstGeom prst="rect">
-            <a:avLst/>
-          </a:prstGeom>
-          <a:noFill/>
-        </p:spPr>
-        <p:txBody>
-          <a:bodyPr wrap="none" tIns="0" bIns="0" lIns="0" rIns="0">
-            <a:spAutoFit/>
-          </a:bodyPr>
-          <a:lstStyle/>
-          <a:p>
-            <a:pPr algn="l"/>
-            <a:r>
-              <a:rPr sz="1000" b="1">
-                <a:solidFill>
-                  <a:srgbClr val="6E899D"/>
-                </a:solidFill>
-                <a:latin typeface="Arial"/>
-              </a:rPr>
-              <a:t>EDITABLE COLLABORATION LOOP</a:t>
-            </a:r>
-          </a:p>
-        </p:txBody>
-      </p:sp>
-      <p:sp>
-        <p:nvSpPr>
-          <p:cNvPr id="28" name="TextBox 27"/>
-          <p:cNvSpPr txBox="1"/>
-          <p:nvPr/>
-        </p:nvSpPr>
-        <p:spPr>
-          <a:xfrm>
-            <a:off x="3407664" y="5433060"/>
-            <a:ext cx="824992" cy="145288"/>
-          </a:xfrm>
-          <a:prstGeom prst="rect">
-            <a:avLst/>
-          </a:prstGeom>
-          <a:noFill/>
-        </p:spPr>
-        <p:txBody>
-          <a:bodyPr wrap="none" tIns="0" bIns="0" lIns="0" rIns="0">
-            <a:spAutoFit/>
-          </a:bodyPr>
-          <a:lstStyle/>
-          <a:p>
-            <a:pPr algn="ctr"/>
-            <a:r>
-              <a:rPr sz="1100" b="1">
-                <a:solidFill>
-                  <a:srgbClr val="15334A"/>
-                </a:solidFill>
-                <a:latin typeface="Arial"/>
-              </a:rPr>
-              <a:t>QUESTION</a:t>
-            </a:r>
-          </a:p>
-        </p:txBody>
-      </p:sp>
-      <p:sp>
-        <p:nvSpPr>
-          <p:cNvPr id="29" name="TextBox 28"/>
-          <p:cNvSpPr txBox="1"/>
-          <p:nvPr/>
-        </p:nvSpPr>
-        <p:spPr>
-          <a:xfrm>
-            <a:off x="3516630" y="5626100"/>
-            <a:ext cx="607060" cy="145288"/>
-          </a:xfrm>
-          <a:prstGeom prst="rect">
-            <a:avLst/>
-          </a:prstGeom>
-          <a:noFill/>
-        </p:spPr>
-        <p:txBody>
-          <a:bodyPr wrap="none" tIns="0" bIns="0" lIns="0" rIns="0">
-            <a:spAutoFit/>
-          </a:bodyPr>
-          <a:lstStyle/>
-          <a:p>
-            <a:pPr algn="ctr"/>
-            <a:r>
-              <a:rPr sz="1100">
-                <a:solidFill>
-                  <a:srgbClr val="557085"/>
-                </a:solidFill>
-                <a:latin typeface="Arial"/>
-              </a:rPr>
-              <a:t>frame</a:t>
-            </a:r>
-          </a:p>
-        </p:txBody>
-      </p:sp>
-      <p:sp>
-        <p:nvSpPr>
-          <p:cNvPr id="30" name="TextBox 29"/>
-          <p:cNvSpPr txBox="1"/>
-          <p:nvPr/>
-        </p:nvSpPr>
-        <p:spPr>
-          <a:xfrm>
-            <a:off x="4919980" y="5433060"/>
-            <a:ext cx="970280" cy="145288"/>
-          </a:xfrm>
-          <a:prstGeom prst="rect">
-            <a:avLst/>
-          </a:prstGeom>
-          <a:noFill/>
-        </p:spPr>
-        <p:txBody>
-          <a:bodyPr wrap="none" tIns="0" bIns="0" lIns="0" rIns="0">
-            <a:spAutoFit/>
-          </a:bodyPr>
-          <a:lstStyle/>
-          <a:p>
-            <a:pPr algn="ctr"/>
-            <a:r>
-              <a:rPr sz="1100" b="1">
-                <a:solidFill>
-                  <a:srgbClr val="15334A"/>
-                </a:solidFill>
-                <a:latin typeface="Arial"/>
-              </a:rPr>
-              <a:t>EXPERIMENT</a:t>
-            </a:r>
-          </a:p>
-        </p:txBody>
-      </p:sp>
-      <p:sp>
-        <p:nvSpPr>
-          <p:cNvPr id="31" name="TextBox 30"/>
-          <p:cNvSpPr txBox="1"/>
-          <p:nvPr/>
-        </p:nvSpPr>
-        <p:spPr>
-          <a:xfrm>
-            <a:off x="5101590" y="5626100"/>
-            <a:ext cx="607060" cy="145288"/>
-          </a:xfrm>
-          <a:prstGeom prst="rect">
-            <a:avLst/>
-          </a:prstGeom>
-          <a:noFill/>
-        </p:spPr>
-        <p:txBody>
-          <a:bodyPr wrap="none" tIns="0" bIns="0" lIns="0" rIns="0">
-            <a:spAutoFit/>
-          </a:bodyPr>
-          <a:lstStyle/>
-          <a:p>
-            <a:pPr algn="ctr"/>
-            <a:r>
-              <a:rPr sz="1100">
-                <a:solidFill>
-                  <a:srgbClr val="557085"/>
-                </a:solidFill>
-                <a:latin typeface="Arial"/>
-              </a:rPr>
-              <a:t>probe</a:t>
-            </a:r>
-          </a:p>
-        </p:txBody>
-      </p:sp>
-      <p:sp>
-        <p:nvSpPr>
-          <p:cNvPr id="32" name="TextBox 31"/>
-          <p:cNvSpPr txBox="1"/>
-          <p:nvPr/>
-        </p:nvSpPr>
-        <p:spPr>
-          <a:xfrm>
-            <a:off x="6577584" y="5433060"/>
-            <a:ext cx="824992" cy="145288"/>
-          </a:xfrm>
-          <a:prstGeom prst="rect">
-            <a:avLst/>
-          </a:prstGeom>
-          <a:noFill/>
-        </p:spPr>
-        <p:txBody>
-          <a:bodyPr wrap="none" tIns="0" bIns="0" lIns="0" rIns="0">
-            <a:spAutoFit/>
-          </a:bodyPr>
-          <a:lstStyle/>
-          <a:p>
-            <a:pPr algn="ctr"/>
-            <a:r>
-              <a:rPr sz="1100" b="1">
-                <a:solidFill>
-                  <a:srgbClr val="15334A"/>
-                </a:solidFill>
-                <a:latin typeface="Arial"/>
-              </a:rPr>
-              <a:t>JUDGMENT</a:t>
-            </a:r>
-          </a:p>
-        </p:txBody>
-      </p:sp>
-      <p:sp>
-        <p:nvSpPr>
-          <p:cNvPr id="33" name="TextBox 32"/>
-          <p:cNvSpPr txBox="1"/>
-          <p:nvPr/>
-        </p:nvSpPr>
-        <p:spPr>
-          <a:xfrm>
-            <a:off x="6650228" y="5626100"/>
-            <a:ext cx="679704" cy="145288"/>
-          </a:xfrm>
-          <a:prstGeom prst="rect">
-            <a:avLst/>
-          </a:prstGeom>
-          <a:noFill/>
-        </p:spPr>
-        <p:txBody>
-          <a:bodyPr wrap="none" tIns="0" bIns="0" lIns="0" rIns="0">
-            <a:spAutoFit/>
-          </a:bodyPr>
-          <a:lstStyle/>
-          <a:p>
-            <a:pPr algn="ctr"/>
-            <a:r>
-              <a:rPr sz="1100">
-                <a:solidFill>
-                  <a:srgbClr val="8B6840"/>
-                </a:solidFill>
-                <a:latin typeface="Arial"/>
-              </a:rPr>
-              <a:t>review</a:t>
-            </a:r>
-          </a:p>
-        </p:txBody>
-      </p:sp>
-      <p:sp>
-        <p:nvSpPr>
-          <p:cNvPr id="34" name="TextBox 33"/>
-          <p:cNvSpPr txBox="1"/>
-          <p:nvPr/>
-        </p:nvSpPr>
-        <p:spPr>
-          <a:xfrm>
-            <a:off x="731520" y="6121400"/>
-            <a:ext cx="5461000" cy="132080"/>
-          </a:xfrm>
-          <a:prstGeom prst="rect">
-            <a:avLst/>
-          </a:prstGeom>
-          <a:noFill/>
-        </p:spPr>
-        <p:txBody>
-          <a:bodyPr wrap="none" tIns="0" bIns="0" lIns="0" rIns="0">
-            <a:spAutoFit/>
-          </a:bodyPr>
-          <a:lstStyle/>
-          <a:p>
-            <a:pPr algn="l"/>
-            <a:r>
-              <a:rPr sz="1000">
-                <a:solidFill>
-                  <a:srgbClr val="7892A4"/>
-                </a:solidFill>
-                <a:latin typeface="Arial"/>
-              </a:rPr>
-              <a:t>Illustrative AI-generated base only • factual callouts remain editable overlays</a:t>
-            </a:r>
           </a:p>
         </p:txBody>
       </p:sp>

</xml_diff>